<commit_message>
fix(docs): update tools comparison image and presentation
</commit_message>
<xml_diff>
--- a/notes/tools/tools-comparison.pptx
+++ b/notes/tools/tools-comparison.pptx
@@ -3492,7 +3492,7 @@
           <p:nvPr>
             <p:extLst>
               <p:ext uri="{D42A27DB-BD31-4B8C-83A1-F6EECF244321}">
-                <p14:modId xmlns:p14="http://schemas.microsoft.com/office/powerpoint/2010/main" val="1136765743"/>
+                <p14:modId xmlns:p14="http://schemas.microsoft.com/office/powerpoint/2010/main" val="2995404135"/>
               </p:ext>
             </p:extLst>
           </p:nvPr>
@@ -4165,6 +4165,36 @@
                         <a:t>❓</a:t>
                       </a:r>
                     </a:p>
+                    <a:p>
+                      <a:pPr marL="0" marR="0" lvl="0" indent="0" algn="ctr" defTabSz="914400" rtl="0" eaLnBrk="1" fontAlgn="auto" latinLnBrk="0" hangingPunct="1">
+                        <a:lnSpc>
+                          <a:spcPct val="100000"/>
+                        </a:lnSpc>
+                        <a:spcBef>
+                          <a:spcPts val="0"/>
+                        </a:spcBef>
+                        <a:spcAft>
+                          <a:spcPts val="0"/>
+                        </a:spcAft>
+                        <a:buClrTx/>
+                        <a:buSzTx/>
+                        <a:buFontTx/>
+                        <a:buNone/>
+                        <a:tabLst/>
+                        <a:defRPr/>
+                      </a:pPr>
+                      <a:r>
+                        <a:rPr lang="en-US" sz="900" kern="1200" dirty="0">
+                          <a:solidFill>
+                            <a:schemeClr val="dk1"/>
+                          </a:solidFill>
+                          <a:latin typeface="+mn-lt"/>
+                          <a:ea typeface="+mn-ea"/>
+                          <a:cs typeface="+mn-cs"/>
+                        </a:rPr>
+                        <a:t>No guarantees - It does not handle the re-schedule</a:t>
+                      </a:r>
+                    </a:p>
                   </a:txBody>
                   <a:tcPr marL="137355" marR="137355" marT="68678" marB="68678" anchor="ctr"/>
                 </a:tc>
@@ -4585,7 +4615,23 @@
                             <a:srgbClr val="FF0000"/>
                           </a:solidFill>
                         </a:rPr>
-                        <a:t> the use of a custom scheduler plugin!</a:t>
+                        <a:t> the use of a </a:t>
+                      </a:r>
+                      <a:r>
+                        <a:rPr lang="en-US" sz="900" baseline="0" dirty="0" err="1">
+                          <a:solidFill>
+                            <a:srgbClr val="FF0000"/>
+                          </a:solidFill>
+                        </a:rPr>
+                        <a:t>customplugin</a:t>
+                      </a:r>
+                      <a:r>
+                        <a:rPr lang="en-US" sz="900" baseline="0" dirty="0">
+                          <a:solidFill>
+                            <a:srgbClr val="FF0000"/>
+                          </a:solidFill>
+                        </a:rPr>
+                        <a:t>!</a:t>
                       </a:r>
                       <a:endParaRPr lang="en-US" sz="900" dirty="0">
                         <a:solidFill>
@@ -4954,7 +5000,7 @@
                       </a:r>
                       <a:r>
                         <a:rPr lang="en-US" sz="1050" baseline="0" dirty="0"/>
-                        <a:t> (as long as you can enable the scoring strategy – or deploy a custom scheduler))</a:t>
+                        <a:t> (as long as you can enable the scoring strategy – or deploy a custom scheduler)</a:t>
                       </a:r>
                       <a:endParaRPr lang="en-US" sz="1050" kern="1200" dirty="0">
                         <a:solidFill>
@@ -4980,7 +5026,11 @@
                       </a:r>
                       <a:r>
                         <a:rPr lang="en-US" sz="1050" baseline="0" dirty="0"/>
-                        <a:t> of them (as long as you can enable the scoring plugin – or deploy a custom scheduler)</a:t>
+                        <a:t> of them (as long as you can use the scoring plugin – maybe deploy </a:t>
+                      </a:r>
+                      <a:r>
+                        <a:rPr lang="en-US" sz="1050" baseline="0"/>
+                        <a:t>a second custom scheduler?)</a:t>
                       </a:r>
                       <a:endParaRPr lang="en-US" sz="1050" dirty="0"/>
                     </a:p>

</xml_diff>